<commit_message>
docs: refresh the NanoJev presentation demo
Use the completed 16x16 maze recording on slide 11 with the requested
full-system emulation and hardware virtualization captions.

Validation: 12-slide package, fonts, native tables and charts, embedded
GIF bytes, and visual inspection passed. Every other slide remains
pixel-identical, including the final Q&A and QR codes.

Signed-off-by: Chao Liu <chao.liu@processmission.com>
</commit_message>
<xml_diff>
--- a/docs/slides/qemu-on-zephyr.pptx
+++ b/docs/slides/qemu-on-zephyr.pptx
@@ -2,24 +2,24 @@
 <file path=ppt/presentation.xml><?xml version="1.0" encoding="utf-8"?>
 <p:presentation xmlns:p="http://schemas.openxmlformats.org/presentationml/2006/main">
   <p:sldMasterIdLst>
-    <p:sldMasterId xmlns:r="http://schemas.openxmlformats.org/officeDocument/2006/relationships" id="2147483648" r:id="Rff3632d177aa4aa0"/>
+    <p:sldMasterId xmlns:r="http://schemas.openxmlformats.org/officeDocument/2006/relationships" id="2147483648" r:id="Rbdcaa5649f2844f6"/>
   </p:sldMasterIdLst>
   <p:notesMasterIdLst>
-    <p:notesMasterId xmlns:r="http://schemas.openxmlformats.org/officeDocument/2006/relationships" r:id="R72af64b4091c47a3"/>
+    <p:notesMasterId xmlns:r="http://schemas.openxmlformats.org/officeDocument/2006/relationships" r:id="Rfbaafdeead7c4c7a"/>
   </p:notesMasterIdLst>
   <p:sldIdLst>
-    <p:sldId xmlns:r="http://schemas.openxmlformats.org/officeDocument/2006/relationships" id="256" r:id="R7626a6626d284e38"/>
-    <p:sldId xmlns:r="http://schemas.openxmlformats.org/officeDocument/2006/relationships" id="257" r:id="R5851634ec01449ca"/>
-    <p:sldId xmlns:r="http://schemas.openxmlformats.org/officeDocument/2006/relationships" id="258" r:id="R22286d904d724dbb"/>
-    <p:sldId xmlns:r="http://schemas.openxmlformats.org/officeDocument/2006/relationships" id="259" r:id="Rb600b69716b6455d"/>
-    <p:sldId xmlns:r="http://schemas.openxmlformats.org/officeDocument/2006/relationships" id="260" r:id="Rbb51198df1724454"/>
-    <p:sldId xmlns:r="http://schemas.openxmlformats.org/officeDocument/2006/relationships" id="261" r:id="Radb70d3b80114425"/>
-    <p:sldId xmlns:r="http://schemas.openxmlformats.org/officeDocument/2006/relationships" id="262" r:id="Re97471f374884048"/>
-    <p:sldId xmlns:r="http://schemas.openxmlformats.org/officeDocument/2006/relationships" id="263" r:id="R502d6fcada2440ca"/>
-    <p:sldId xmlns:r="http://schemas.openxmlformats.org/officeDocument/2006/relationships" id="264" r:id="R8a5ceec6d7ca4f7c"/>
-    <p:sldId xmlns:r="http://schemas.openxmlformats.org/officeDocument/2006/relationships" id="265" r:id="Rcad8bcd819eb40bd"/>
-    <p:sldId xmlns:r="http://schemas.openxmlformats.org/officeDocument/2006/relationships" id="266" r:id="R1b2d6d98212a4f30"/>
-    <p:sldId xmlns:r="http://schemas.openxmlformats.org/officeDocument/2006/relationships" id="267" r:id="R17709a6c8e184773"/>
+    <p:sldId xmlns:r="http://schemas.openxmlformats.org/officeDocument/2006/relationships" id="256" r:id="R66540fe4e5a844c3"/>
+    <p:sldId xmlns:r="http://schemas.openxmlformats.org/officeDocument/2006/relationships" id="257" r:id="R61966044a6434ea1"/>
+    <p:sldId xmlns:r="http://schemas.openxmlformats.org/officeDocument/2006/relationships" id="258" r:id="R846f0997019e4b1a"/>
+    <p:sldId xmlns:r="http://schemas.openxmlformats.org/officeDocument/2006/relationships" id="259" r:id="R92e4aa9981924c2d"/>
+    <p:sldId xmlns:r="http://schemas.openxmlformats.org/officeDocument/2006/relationships" id="260" r:id="Rbe01d5a16d8142c6"/>
+    <p:sldId xmlns:r="http://schemas.openxmlformats.org/officeDocument/2006/relationships" id="261" r:id="R1463b887fc3b47a3"/>
+    <p:sldId xmlns:r="http://schemas.openxmlformats.org/officeDocument/2006/relationships" id="262" r:id="R7ab07cfe37474d09"/>
+    <p:sldId xmlns:r="http://schemas.openxmlformats.org/officeDocument/2006/relationships" id="263" r:id="R05c19c8f4df94c26"/>
+    <p:sldId xmlns:r="http://schemas.openxmlformats.org/officeDocument/2006/relationships" id="264" r:id="R67ab92bc99e84a51"/>
+    <p:sldId xmlns:r="http://schemas.openxmlformats.org/officeDocument/2006/relationships" id="265" r:id="Rc67cc3e6c70d4158"/>
+    <p:sldId xmlns:r="http://schemas.openxmlformats.org/officeDocument/2006/relationships" id="266" r:id="Re3125d78bc9d4d32"/>
+    <p:sldId xmlns:r="http://schemas.openxmlformats.org/officeDocument/2006/relationships" id="267" r:id="R0cad42e14446414b"/>
   </p:sldIdLst>
   <p:sldSz cx="12192000" cy="6858000"/>
   <p:notesSz cx="6858000" cy="9144000"/>
@@ -653,27 +653,27 @@
           <a:lstStyle xmlns:a="http://schemas.openxmlformats.org/drawingml/2006/main"/>
           <a:p xmlns:a="http://schemas.openxmlformats.org/drawingml/2006/main">
             <a:r>
-              <a:t>演示在 QEMU on Zephyr 的全系统模式中运行 NanoJev。内层使用 -accel zephyr，由 ZHV 在 EL2 执行 Linux 客体。</a:t>
+              <a:t>演示在 QEMU on Zephyr 全系统模拟模式中运行 NanoJev 大模型推理，采用硬件虚拟化加速。</a:t>
             </a:r>
           </a:p>
           <a:p xmlns:a="http://schemas.openxmlformats.org/drawingml/2006/main">
             <a:r>
-              <a:t>CPU 推理采用 PyTorch QNNPACK 动态 INT8，嵌入层、归一化和决策头使用 FP32。模型只读取镜像中的本地权重。</a:t>
+              <a:t>Debian ARM64 桌面运行 Qwen3-0.6B，线性层使用动态 INT8 量化，嵌入层、归一化和决策头使用 FP32。模型读取本地权重。</a:t>
             </a:r>
           </a:p>
           <a:p xmlns:a="http://schemas.openxmlformats.org/drawingml/2006/main">
             <a:r>
-              <a:t>运行环境：外层 QEMU hvf,kernel-irqchip=on，内层 Zephyr 和 Linux。界面中的耗时对应此运行环境。</a:t>
+              <a:t>实际运行完成 65 次移动尝试、58 次模型调用，经过 7 次碰撞后抵达目标。</a:t>
             </a:r>
           </a:p>
           <a:p xmlns:a="http://schemas.openxmlformats.org/drawingml/2006/main">
             <a:r>
-              <a:t>GIF 保留完整迷宫执行，启动和模型初始化片段加速 12 倍。原速视频、模型输出和串口日志见 build/nanojev-final-validation。</a:t>
+              <a:t>16 × 16 迷宫采用 loops 生成器和随机种子 17，包含 21 个岔路口、12 个独立环路和 2 个死路。</a:t>
             </a:r>
           </a:p>
           <a:p xmlns:a="http://schemas.openxmlformats.org/drawingml/2006/main">
             <a:r>
-              <a:t>实际验证：19 次迷宫操作，16 次模型调用，196 个 INT8 线性模块。</a:t>
+              <a:t>原始视频、模型输出和串口日志：build/nanojev-branched-validation。</a:t>
             </a:r>
           </a:p>
           <a:p xmlns:a="http://schemas.openxmlformats.org/drawingml/2006/main">
@@ -683,7 +683,7 @@
           </a:p>
           <a:p xmlns:a="http://schemas.openxmlformats.org/drawingml/2006/main">
             <a:r>
-              <a:t>CPU 实现：https://github.com/LeanFly/NanoJev/tree/9a5238fe86ca687ba264aabe0d26d77b3b93f939</a:t>
+              <a:t>运行实现：https://github.com/LeanFly/NanoJev/tree/9a5238fe86ca687ba264aabe0d26d77b3b93f939</a:t>
             </a:r>
           </a:p>
           <a:p xmlns:a="http://schemas.openxmlformats.org/drawingml/2006/main">
@@ -1861,7 +1861,7 @@
           <p:cNvPr id="5" name="图片 4">
             <a:extLst xmlns:a="http://schemas.openxmlformats.org/drawingml/2006/main">
               <a:ext uri="{FF2B5EF4-FFF2-40B4-BE49-F238E27FC236}">
-                <a16:creationId xmlns:a16="http://schemas.microsoft.com/office/drawing/2014/main" id="{B107B3B2-66ED-4FFA-ACF8-51AA3E496295}"/>
+                <a16:creationId xmlns:a16="http://schemas.microsoft.com/office/drawing/2014/main" id="{30B320C7-86F6-42B7-950E-C7DC923167A5}"/>
               </a:ext>
             </a:extLst>
           </p:cNvPr>
@@ -1871,7 +1871,7 @@
           <p:nvPr/>
         </p:nvPicPr>
         <p:blipFill>
-          <a:blip xmlns:r="http://schemas.openxmlformats.org/officeDocument/2006/relationships" xmlns:a="http://schemas.openxmlformats.org/drawingml/2006/main" r:embed="R99bb799be329418c"/>
+          <a:blip xmlns:r="http://schemas.openxmlformats.org/officeDocument/2006/relationships" xmlns:a="http://schemas.openxmlformats.org/drawingml/2006/main" r:embed="R18760b748db142d3"/>
           <a:stretch xmlns:a="http://schemas.openxmlformats.org/drawingml/2006/main">
             <a:fillRect l="0" t="0" r="0" b="0"/>
           </a:stretch>
@@ -2257,9 +2257,9 @@
   </p:cSld>
   <p:clrMap bg1="lt1" tx1="dk1" bg2="lt2" tx2="dk2" accent1="accent1" accent2="accent2" accent3="accent3" accent4="accent4" accent5="accent5" accent6="accent6" hlink="hlink" folHlink="folHlink"/>
   <p:sldLayoutIdLst>
-    <p:sldLayoutId xmlns:r="http://schemas.openxmlformats.org/officeDocument/2006/relationships" id="2147483649" r:id="R2cbd0aab3cd649e3"/>
-    <p:sldLayoutId xmlns:r="http://schemas.openxmlformats.org/officeDocument/2006/relationships" id="2147483650" r:id="R17b6585e970d4215"/>
-    <p:sldLayoutId xmlns:r="http://schemas.openxmlformats.org/officeDocument/2006/relationships" id="2147483651" r:id="Rc3c0014d12d44603"/>
+    <p:sldLayoutId xmlns:r="http://schemas.openxmlformats.org/officeDocument/2006/relationships" id="2147483649" r:id="R88f0dbf2296441cb"/>
+    <p:sldLayoutId xmlns:r="http://schemas.openxmlformats.org/officeDocument/2006/relationships" id="2147483650" r:id="Rfb14c9ad0d2147a1"/>
+    <p:sldLayoutId xmlns:r="http://schemas.openxmlformats.org/officeDocument/2006/relationships" id="2147483651" r:id="R5b8f47cdde714fca"/>
   </p:sldLayoutIdLst>
   <p:hf sldNum="0" hdr="0" ftr="0" dt="0"/>
   <p:txStyles>
@@ -2971,7 +2971,7 @@
           <p:cNvPr id="2" name="图片 1">
             <a:extLst xmlns:a="http://schemas.openxmlformats.org/drawingml/2006/main">
               <a:ext uri="{FF2B5EF4-FFF2-40B4-BE49-F238E27FC236}">
-                <a16:creationId xmlns:a16="http://schemas.microsoft.com/office/drawing/2014/main" id="{B52B0C09-23B3-436A-9E70-C74CD69A07EF}"/>
+                <a16:creationId xmlns:a16="http://schemas.microsoft.com/office/drawing/2014/main" id="{B9898034-FBBF-4D85-AC7A-015F4E42D541}"/>
               </a:ext>
             </a:extLst>
           </p:cNvPr>
@@ -2981,7 +2981,7 @@
           <p:nvPr/>
         </p:nvPicPr>
         <p:blipFill>
-          <a:blip xmlns:r="http://schemas.openxmlformats.org/officeDocument/2006/relationships" xmlns:a="http://schemas.openxmlformats.org/drawingml/2006/main" r:embed="R1fdf6a931aa847ab">
+          <a:blip xmlns:r="http://schemas.openxmlformats.org/officeDocument/2006/relationships" xmlns:a="http://schemas.openxmlformats.org/drawingml/2006/main" r:embed="R2868344af9e44de4">
             <a:alphaModFix amt="40000"/>
           </a:blip>
           <a:stretch xmlns:a="http://schemas.openxmlformats.org/drawingml/2006/main">
@@ -3436,7 +3436,7 @@
           <p:cNvPr id="9" name="图片 8">
             <a:extLst xmlns:a="http://schemas.openxmlformats.org/drawingml/2006/main">
               <a:ext uri="{FF2B5EF4-FFF2-40B4-BE49-F238E27FC236}">
-                <a16:creationId xmlns:a16="http://schemas.microsoft.com/office/drawing/2014/main" id="{963AD3B0-AF2F-4D79-8FB4-CBFB274D7F9B}"/>
+                <a16:creationId xmlns:a16="http://schemas.microsoft.com/office/drawing/2014/main" id="{D4748478-B089-4AB7-BD65-4A135F763793}"/>
               </a:ext>
             </a:extLst>
           </p:cNvPr>
@@ -3446,7 +3446,7 @@
           <p:nvPr/>
         </p:nvPicPr>
         <p:blipFill>
-          <a:blip xmlns:r="http://schemas.openxmlformats.org/officeDocument/2006/relationships" xmlns:a="http://schemas.openxmlformats.org/drawingml/2006/main" r:embed="R9b7e576a46944fb0">
+          <a:blip xmlns:r="http://schemas.openxmlformats.org/officeDocument/2006/relationships" xmlns:a="http://schemas.openxmlformats.org/drawingml/2006/main" r:embed="Re2290943aea6400a">
             <a:clrChange>
               <a:clrFrom>
                 <a:srgbClr val="FFFFFF"/>
@@ -3950,7 +3950,7 @@
           <p:cNvPr id="6" name="">
             <a:extLst xmlns:a="http://schemas.openxmlformats.org/drawingml/2006/main">
               <a:ext uri="{FF2B5EF4-FFF2-40B4-BE49-F238E27FC236}">
-                <a16:creationId xmlns:a16="http://schemas.microsoft.com/office/drawing/2014/main" id="{D8968F03-48EE-4F31-A74F-54EDBA65499F}"/>
+                <a16:creationId xmlns:a16="http://schemas.microsoft.com/office/drawing/2014/main" id="{FAD0ACB5-8A95-4EB2-BE29-B619D77AC4BD}"/>
               </a:ext>
             </a:extLst>
           </p:cNvPr>
@@ -3960,7 +3960,7 @@
           <p:nvPr/>
         </p:nvPicPr>
         <p:blipFill>
-          <a:blip xmlns:r="http://schemas.openxmlformats.org/officeDocument/2006/relationships" xmlns:a="http://schemas.openxmlformats.org/drawingml/2006/main" r:embed="Rbe4e22ba23b64f3c"/>
+          <a:blip xmlns:r="http://schemas.openxmlformats.org/officeDocument/2006/relationships" xmlns:a="http://schemas.openxmlformats.org/drawingml/2006/main" r:embed="R4ab6d52503564b45"/>
           <a:stretch xmlns:a="http://schemas.openxmlformats.org/drawingml/2006/main"/>
         </p:blipFill>
         <p:spPr>
@@ -3978,7 +3978,7 @@
           <p:cNvPr id="7" name="">
             <a:extLst xmlns:a="http://schemas.openxmlformats.org/drawingml/2006/main">
               <a:ext uri="{FF2B5EF4-FFF2-40B4-BE49-F238E27FC236}">
-                <a16:creationId xmlns:a16="http://schemas.microsoft.com/office/drawing/2014/main" id="{40E072F7-9CE3-4275-B501-D273DC2A6AC9}"/>
+                <a16:creationId xmlns:a16="http://schemas.microsoft.com/office/drawing/2014/main" id="{CDDD6278-24DF-44FA-99FC-A1EDA385C53B}"/>
               </a:ext>
             </a:extLst>
           </p:cNvPr>
@@ -3988,7 +3988,7 @@
           <p:nvPr/>
         </p:nvPicPr>
         <p:blipFill>
-          <a:blip xmlns:r="http://schemas.openxmlformats.org/officeDocument/2006/relationships" xmlns:a="http://schemas.openxmlformats.org/drawingml/2006/main" r:embed="R7411299f707e4bfa"/>
+          <a:blip xmlns:r="http://schemas.openxmlformats.org/officeDocument/2006/relationships" xmlns:a="http://schemas.openxmlformats.org/drawingml/2006/main" r:embed="R152c769ab4864b55"/>
           <a:stretch xmlns:a="http://schemas.openxmlformats.org/drawingml/2006/main"/>
         </p:blipFill>
         <p:spPr>
@@ -4202,6 +4202,7 @@
           </a:lstStyle>
           <a:p xmlns:a="http://schemas.openxmlformats.org/drawingml/2006/main">
             <a:pPr algn="l">
+              <a:buNone/>
               <a:defRPr sz="2400" b="1">
                 <a:solidFill>
                   <a:srgbClr val="1D1D1D"/>
@@ -4220,7 +4221,7 @@
                 <a:ea typeface="Microsoft YaHei"/>
                 <a:cs typeface="Microsoft YaHei"/>
               </a:rPr>
-              <a:t>NanoJev CPU 推理演示</a:t>
+              <a:t>运行 NanoJev 大模型推理</a:t>
             </a:r>
           </a:p>
         </p:txBody>
@@ -4230,7 +4231,7 @@
           <p:cNvPr id="2" name="">
             <a:extLst xmlns:a="http://schemas.openxmlformats.org/drawingml/2006/main">
               <a:ext uri="{FF2B5EF4-FFF2-40B4-BE49-F238E27FC236}">
-                <a16:creationId xmlns:a16="http://schemas.microsoft.com/office/drawing/2014/main" id="{3B631899-CBFC-4F65-9128-AC227ECF29BB}"/>
+                <a16:creationId xmlns:a16="http://schemas.microsoft.com/office/drawing/2014/main" id="{73E3CB9C-F4D8-41B5-A79A-6AA9A931DC72}"/>
               </a:ext>
             </a:extLst>
           </p:cNvPr>
@@ -4240,7 +4241,7 @@
           <p:nvPr/>
         </p:nvPicPr>
         <p:blipFill>
-          <a:blip xmlns:r="http://schemas.openxmlformats.org/officeDocument/2006/relationships" xmlns:a="http://schemas.openxmlformats.org/drawingml/2006/main" r:embed="Rf60b2c2ce41f4e6e"/>
+          <a:blip xmlns:r="http://schemas.openxmlformats.org/officeDocument/2006/relationships" xmlns:a="http://schemas.openxmlformats.org/drawingml/2006/main" r:embed="R7edf6a29072b4dee"/>
           <a:stretch xmlns:a="http://schemas.openxmlformats.org/drawingml/2006/main"/>
         </p:blipFill>
         <p:spPr>
@@ -4296,6 +4297,7 @@
           </a:lstStyle>
           <a:p xmlns:a="http://schemas.openxmlformats.org/drawingml/2006/main">
             <a:pPr algn="l">
+              <a:buNone/>
               <a:defRPr sz="2025" b="1">
                 <a:solidFill>
                   <a:srgbClr val="B1270A"/>
@@ -4314,7 +4316,7 @@
                 <a:ea typeface="Microsoft YaHei"/>
                 <a:cs typeface="Microsoft YaHei"/>
               </a:rPr>
-              <a:t>ZHV EL2 硬件虚拟化</a:t>
+              <a:t>QEMU on Zephyr 全系统模拟</a:t>
             </a:r>
           </a:p>
         </p:txBody>
@@ -4362,6 +4364,7 @@
           </a:lstStyle>
           <a:p xmlns:a="http://schemas.openxmlformats.org/drawingml/2006/main">
             <a:pPr algn="l">
+              <a:buNone/>
               <a:defRPr sz="1875" b="0">
                 <a:solidFill>
                   <a:srgbClr val="1D1D1D"/>
@@ -4385,6 +4388,7 @@
           </a:p>
           <a:p xmlns:a="http://schemas.openxmlformats.org/drawingml/2006/main">
             <a:pPr algn="l">
+              <a:buNone/>
               <a:defRPr sz="1875" b="0">
                 <a:solidFill>
                   <a:srgbClr val="1D1D1D"/>
@@ -4403,7 +4407,7 @@
                 <a:ea typeface="Microsoft YaHei"/>
                 <a:cs typeface="Microsoft YaHei"/>
               </a:rPr>
-              <a:t>执行 NanoJev CPU 推理</a:t>
+              <a:t>执行 NanoJev 大模型推理</a:t>
             </a:r>
           </a:p>
         </p:txBody>
@@ -4451,6 +4455,7 @@
           </a:lstStyle>
           <a:p xmlns:a="http://schemas.openxmlformats.org/drawingml/2006/main">
             <a:pPr algn="l">
+              <a:buNone/>
               <a:defRPr sz="1650" b="0">
                 <a:solidFill>
                   <a:srgbClr val="666666"/>
@@ -4474,6 +4479,7 @@
           </a:p>
           <a:p xmlns:a="http://schemas.openxmlformats.org/drawingml/2006/main">
             <a:pPr algn="l">
+              <a:buNone/>
               <a:defRPr sz="1650" b="0">
                 <a:solidFill>
                   <a:srgbClr val="666666"/>
@@ -4497,6 +4503,7 @@
           </a:p>
           <a:p xmlns:a="http://schemas.openxmlformats.org/drawingml/2006/main">
             <a:pPr algn="l">
+              <a:buNone/>
               <a:defRPr sz="1650" b="0">
                 <a:solidFill>
                   <a:srgbClr val="666666"/>
@@ -4563,6 +4570,7 @@
           </a:lstStyle>
           <a:p xmlns:a="http://schemas.openxmlformats.org/drawingml/2006/main">
             <a:pPr algn="l">
+              <a:buNone/>
               <a:defRPr sz="1725" b="0">
                 <a:solidFill>
                   <a:srgbClr val="1D1D1D"/>
@@ -4581,119 +4589,7 @@
                 <a:ea typeface="Microsoft YaHei"/>
                 <a:cs typeface="Microsoft YaHei"/>
               </a:rPr>
-              <a:t>独立镜像与 CI</a:t>
-            </a:r>
-          </a:p>
-          <a:p xmlns:a="http://schemas.openxmlformats.org/drawingml/2006/main">
-            <a:pPr algn="l">
-              <a:defRPr sz="1725" b="0">
-                <a:solidFill>
-                  <a:srgbClr val="1D1D1D"/>
-                </a:solidFill>
-                <a:latin typeface="Microsoft YaHei"/>
-                <a:ea typeface="Microsoft YaHei"/>
-                <a:cs typeface="Microsoft YaHei"/>
-              </a:defRPr>
-            </a:pPr>
-            <a:r>
-              <a:rPr sz="1725" b="0">
-                <a:solidFill>
-                  <a:srgbClr val="1D1D1D"/>
-                </a:solidFill>
-                <a:latin typeface="Microsoft YaHei"/>
-                <a:ea typeface="Microsoft YaHei"/>
-                <a:cs typeface="Microsoft YaHei"/>
-              </a:rPr>
-              <a:t>make nanojev</a:t>
-            </a:r>
-          </a:p>
-        </p:txBody>
-      </p:sp>
-      <p:sp>
-        <p:nvSpPr>
-          <p:cNvPr id="7" name="nanojev-playback">
-            <a:extLst xmlns:a="http://schemas.openxmlformats.org/drawingml/2006/main">
-              <a:ext uri="{FF2B5EF4-FFF2-40B4-BE49-F238E27FC236}">
-                <a16:creationId xmlns:a16="http://schemas.microsoft.com/office/drawing/2014/main" id="{71F9E0B7-1F51-4C99-83DC-9DCE7DDC05E7}"/>
-              </a:ext>
-            </a:extLst>
-          </p:cNvPr>
-          <p:cNvSpPr>
-            <a:spLocks xmlns:a="http://schemas.openxmlformats.org/drawingml/2006/main" noGrp="1"/>
-          </p:cNvSpPr>
-          <p:nvPr/>
-        </p:nvSpPr>
-        <p:spPr>
-          <a:xfrm xmlns:a="http://schemas.openxmlformats.org/drawingml/2006/main">
-            <a:off x="7429500" y="5562600"/>
-            <a:ext cx="4095750" cy="609600"/>
-          </a:xfrm>
-          <a:prstGeom xmlns:a="http://schemas.openxmlformats.org/drawingml/2006/main" prst="rect">
-            <a:avLst/>
-          </a:prstGeom>
-          <a:noFill xmlns:a="http://schemas.openxmlformats.org/drawingml/2006/main"/>
-          <a:ln xmlns:a="http://schemas.openxmlformats.org/drawingml/2006/main" w="0">
-            <a:noFill/>
-          </a:ln>
-        </p:spPr>
-        <p:txBody>
-          <a:bodyPr xmlns:a="http://schemas.openxmlformats.org/drawingml/2006/main" lIns="0" tIns="0" rIns="0" bIns="0" anchor="ctr"/>
-          <a:lstStyle xmlns:a="http://schemas.openxmlformats.org/drawingml/2006/main">
-            <a:defPPr algn="l">
-              <a:defRPr sz="1275" b="0">
-                <a:solidFill>
-                  <a:srgbClr val="666666"/>
-                </a:solidFill>
-                <a:latin typeface="Microsoft YaHei"/>
-                <a:ea typeface="Microsoft YaHei"/>
-                <a:cs typeface="Microsoft YaHei"/>
-              </a:defRPr>
-            </a:defPPr>
-          </a:lstStyle>
-          <a:p xmlns:a="http://schemas.openxmlformats.org/drawingml/2006/main">
-            <a:pPr algn="l">
-              <a:defRPr sz="1275" b="0">
-                <a:solidFill>
-                  <a:srgbClr val="666666"/>
-                </a:solidFill>
-                <a:latin typeface="Microsoft YaHei"/>
-                <a:ea typeface="Microsoft YaHei"/>
-                <a:cs typeface="Microsoft YaHei"/>
-              </a:defRPr>
-            </a:pPr>
-            <a:r>
-              <a:rPr sz="1275" b="0">
-                <a:solidFill>
-                  <a:srgbClr val="666666"/>
-                </a:solidFill>
-                <a:latin typeface="Microsoft YaHei"/>
-                <a:ea typeface="Microsoft YaHei"/>
-                <a:cs typeface="Microsoft YaHei"/>
-              </a:rPr>
-              <a:t>启动和初始化 12 倍速</a:t>
-            </a:r>
-          </a:p>
-          <a:p xmlns:a="http://schemas.openxmlformats.org/drawingml/2006/main">
-            <a:pPr algn="l">
-              <a:defRPr sz="1275" b="0">
-                <a:solidFill>
-                  <a:srgbClr val="666666"/>
-                </a:solidFill>
-                <a:latin typeface="Microsoft YaHei"/>
-                <a:ea typeface="Microsoft YaHei"/>
-                <a:cs typeface="Microsoft YaHei"/>
-              </a:defRPr>
-            </a:pPr>
-            <a:r>
-              <a:rPr sz="1275" b="0">
-                <a:solidFill>
-                  <a:srgbClr val="666666"/>
-                </a:solidFill>
-                <a:latin typeface="Microsoft YaHei"/>
-                <a:ea typeface="Microsoft YaHei"/>
-                <a:cs typeface="Microsoft YaHei"/>
-              </a:rPr>
-              <a:t>迷宫执行保持正常速度</a:t>
+              <a:t>采用硬件虚拟化加速</a:t>
             </a:r>
           </a:p>
         </p:txBody>
@@ -4961,7 +4857,7 @@
           <p:cNvPr id="5" name="">
             <a:extLst xmlns:a="http://schemas.openxmlformats.org/drawingml/2006/main">
               <a:ext uri="{FF2B5EF4-FFF2-40B4-BE49-F238E27FC236}">
-                <a16:creationId xmlns:a16="http://schemas.microsoft.com/office/drawing/2014/main" id="{4FF751F5-7860-42B7-A6C3-6729A300D7BA}"/>
+                <a16:creationId xmlns:a16="http://schemas.microsoft.com/office/drawing/2014/main" id="{19AD4AF4-2F8D-4595-A52E-E25F9BE223F6}"/>
               </a:ext>
             </a:extLst>
           </p:cNvPr>
@@ -4971,7 +4867,7 @@
           <p:nvPr/>
         </p:nvPicPr>
         <p:blipFill>
-          <a:blip xmlns:r="http://schemas.openxmlformats.org/officeDocument/2006/relationships" xmlns:a="http://schemas.openxmlformats.org/drawingml/2006/main" r:embed="Rc093b0a369394274"/>
+          <a:blip xmlns:r="http://schemas.openxmlformats.org/officeDocument/2006/relationships" xmlns:a="http://schemas.openxmlformats.org/drawingml/2006/main" r:embed="R1af6a0df379e435f"/>
           <a:stretch xmlns:a="http://schemas.openxmlformats.org/drawingml/2006/main"/>
         </p:blipFill>
         <p:spPr>
@@ -5048,7 +4944,7 @@
                 <a:latin typeface="Microsoft YaHei"/>
                 <a:ea typeface="Microsoft YaHei"/>
                 <a:cs typeface="Microsoft YaHei"/>
-                <a:hlinkClick xmlns:r="http://schemas.openxmlformats.org/officeDocument/2006/relationships" r:id="Re966ee23241e4c8d"/>
+                <a:hlinkClick xmlns:r="http://schemas.openxmlformats.org/officeDocument/2006/relationships" r:id="Rc5b92a77eda54743"/>
               </a:rPr>
               <a:t>https://github.com/processmission/qemu-on-zephyr</a:t>
             </a:r>
@@ -5163,7 +5059,7 @@
           <p:cNvPr id="9" name="">
             <a:extLst xmlns:a="http://schemas.openxmlformats.org/drawingml/2006/main">
               <a:ext uri="{FF2B5EF4-FFF2-40B4-BE49-F238E27FC236}">
-                <a16:creationId xmlns:a16="http://schemas.microsoft.com/office/drawing/2014/main" id="{E774F7CC-B39E-479B-A13E-D382904CD724}"/>
+                <a16:creationId xmlns:a16="http://schemas.microsoft.com/office/drawing/2014/main" id="{84855518-E51F-48B3-82EC-938BE1BDA4B5}"/>
               </a:ext>
             </a:extLst>
           </p:cNvPr>
@@ -5173,7 +5069,7 @@
           <p:nvPr/>
         </p:nvPicPr>
         <p:blipFill>
-          <a:blip xmlns:r="http://schemas.openxmlformats.org/officeDocument/2006/relationships" xmlns:a="http://schemas.openxmlformats.org/drawingml/2006/main" r:embed="R841e1ccdf55643e3"/>
+          <a:blip xmlns:r="http://schemas.openxmlformats.org/officeDocument/2006/relationships" xmlns:a="http://schemas.openxmlformats.org/drawingml/2006/main" r:embed="R979acbc08f4a4757"/>
           <a:stretch xmlns:a="http://schemas.openxmlformats.org/drawingml/2006/main"/>
         </p:blipFill>
         <p:spPr>
@@ -5250,7 +5146,7 @@
                 <a:latin typeface="Microsoft YaHei"/>
                 <a:ea typeface="Microsoft YaHei"/>
                 <a:cs typeface="Microsoft YaHei"/>
-                <a:hlinkClick xmlns:r="http://schemas.openxmlformats.org/officeDocument/2006/relationships" r:id="R824cb673d06f4128"/>
+                <a:hlinkClick xmlns:r="http://schemas.openxmlformats.org/officeDocument/2006/relationships" r:id="Rcd204ade04db454a"/>
               </a:rPr>
               <a:t>https://github.com/processmission/agent-skills</a:t>
             </a:r>
@@ -5354,7 +5250,7 @@
           <p:cNvPr id="39" name="">
             <a:extLst xmlns:a="http://schemas.openxmlformats.org/drawingml/2006/main">
               <a:ext uri="{FF2B5EF4-FFF2-40B4-BE49-F238E27FC236}">
-                <a16:creationId xmlns:a16="http://schemas.microsoft.com/office/drawing/2014/main" id="{0B1EE056-04A5-4DA9-891D-756E9AD64A2D}"/>
+                <a16:creationId xmlns:a16="http://schemas.microsoft.com/office/drawing/2014/main" id="{F93A7554-7348-413A-81DF-5F80BD1B2290}"/>
               </a:ext>
             </a:extLst>
           </p:cNvPr>
@@ -5389,7 +5285,7 @@
           <p:cNvPr id="38" name="">
             <a:extLst xmlns:a="http://schemas.openxmlformats.org/drawingml/2006/main">
               <a:ext uri="{FF2B5EF4-FFF2-40B4-BE49-F238E27FC236}">
-                <a16:creationId xmlns:a16="http://schemas.microsoft.com/office/drawing/2014/main" id="{4D4C36B1-97FA-4DC4-9D71-30F3E0F045B8}"/>
+                <a16:creationId xmlns:a16="http://schemas.microsoft.com/office/drawing/2014/main" id="{4EF3C81D-D56F-458C-B1BF-E1F4C3A1ADC7}"/>
               </a:ext>
             </a:extLst>
           </p:cNvPr>
@@ -7414,7 +7310,7 @@
           <p:cNvPr id="7" name="Chart">
             <a:extLst xmlns:a="http://schemas.openxmlformats.org/drawingml/2006/main">
               <a:ext uri="{FF2B5EF4-FFF2-40B4-BE49-F238E27FC236}">
-                <a16:creationId xmlns:a16="http://schemas.microsoft.com/office/drawing/2014/main" id="{0FBA9403-2748-4398-ADA6-77BE0E9AEE52}"/>
+                <a16:creationId xmlns:a16="http://schemas.microsoft.com/office/drawing/2014/main" id="{A093A170-C784-4266-BB8A-E26F845D68C5}"/>
               </a:ext>
             </a:extLst>
           </p:cNvPr>
@@ -7427,7 +7323,7 @@
         </p:xfrm>
         <a:graphic xmlns:a="http://schemas.openxmlformats.org/drawingml/2006/main">
           <a:graphicData uri="http://schemas.openxmlformats.org/drawingml/2006/chart">
-            <c:chart xmlns:r="http://schemas.openxmlformats.org/officeDocument/2006/relationships" xmlns:c="http://schemas.openxmlformats.org/drawingml/2006/chart" r:id="R39bd032beaab4e6c"/>
+            <c:chart xmlns:r="http://schemas.openxmlformats.org/officeDocument/2006/relationships" xmlns:c="http://schemas.openxmlformats.org/drawingml/2006/chart" r:id="Rf34f20fd84124581"/>
           </a:graphicData>
         </a:graphic>
       </p:graphicFrame>
@@ -7436,7 +7332,7 @@
           <p:cNvPr id="8" name="Chart">
             <a:extLst xmlns:a="http://schemas.openxmlformats.org/drawingml/2006/main">
               <a:ext uri="{FF2B5EF4-FFF2-40B4-BE49-F238E27FC236}">
-                <a16:creationId xmlns:a16="http://schemas.microsoft.com/office/drawing/2014/main" id="{8D3C17D6-9BC0-4706-B06A-FD2BAE90550E}"/>
+                <a16:creationId xmlns:a16="http://schemas.microsoft.com/office/drawing/2014/main" id="{C14C49EC-76C9-4FAF-B6F1-49617A8D2F38}"/>
               </a:ext>
             </a:extLst>
           </p:cNvPr>
@@ -7449,7 +7345,7 @@
         </p:xfrm>
         <a:graphic xmlns:a="http://schemas.openxmlformats.org/drawingml/2006/main">
           <a:graphicData uri="http://schemas.openxmlformats.org/drawingml/2006/chart">
-            <c:chart xmlns:r="http://schemas.openxmlformats.org/officeDocument/2006/relationships" xmlns:c="http://schemas.openxmlformats.org/drawingml/2006/chart" r:id="Recd42e837de94663"/>
+            <c:chart xmlns:r="http://schemas.openxmlformats.org/officeDocument/2006/relationships" xmlns:c="http://schemas.openxmlformats.org/drawingml/2006/chart" r:id="R8f80169d3f7b467a"/>
           </a:graphicData>
         </a:graphic>
       </p:graphicFrame>
@@ -8708,7 +8604,7 @@
           <p:cNvPr id="35" name="">
             <a:extLst xmlns:a="http://schemas.openxmlformats.org/drawingml/2006/main">
               <a:ext uri="{FF2B5EF4-FFF2-40B4-BE49-F238E27FC236}">
-                <a16:creationId xmlns:a16="http://schemas.microsoft.com/office/drawing/2014/main" id="{D1A0FC05-EE5A-43D9-A8D0-6505696F0F32}"/>
+                <a16:creationId xmlns:a16="http://schemas.microsoft.com/office/drawing/2014/main" id="{404566B8-5FDC-45D1-9EFC-40EBE2BC715F}"/>
               </a:ext>
             </a:extLst>
           </p:cNvPr>
@@ -8743,7 +8639,7 @@
           <p:cNvPr id="34" name="">
             <a:extLst xmlns:a="http://schemas.openxmlformats.org/drawingml/2006/main">
               <a:ext uri="{FF2B5EF4-FFF2-40B4-BE49-F238E27FC236}">
-                <a16:creationId xmlns:a16="http://schemas.microsoft.com/office/drawing/2014/main" id="{40A30770-E869-4C08-8B0E-C4580E140187}"/>
+                <a16:creationId xmlns:a16="http://schemas.microsoft.com/office/drawing/2014/main" id="{63FD8144-A667-413E-913D-1C11BCF7CA0D}"/>
               </a:ext>
             </a:extLst>
           </p:cNvPr>
@@ -8778,7 +8674,7 @@
           <p:cNvPr id="33" name="">
             <a:extLst xmlns:a="http://schemas.openxmlformats.org/drawingml/2006/main">
               <a:ext uri="{FF2B5EF4-FFF2-40B4-BE49-F238E27FC236}">
-                <a16:creationId xmlns:a16="http://schemas.microsoft.com/office/drawing/2014/main" id="{A0E07B9A-A4D2-4077-85A1-CBC2014BFB25}"/>
+                <a16:creationId xmlns:a16="http://schemas.microsoft.com/office/drawing/2014/main" id="{7A767299-F009-4A25-93C9-9E57357423D6}"/>
               </a:ext>
             </a:extLst>
           </p:cNvPr>
@@ -10202,7 +10098,7 @@
           <p:cNvPr id="36" name="">
             <a:extLst xmlns:a="http://schemas.openxmlformats.org/drawingml/2006/main">
               <a:ext uri="{FF2B5EF4-FFF2-40B4-BE49-F238E27FC236}">
-                <a16:creationId xmlns:a16="http://schemas.microsoft.com/office/drawing/2014/main" id="{02570306-A490-4330-81D3-53555943B473}"/>
+                <a16:creationId xmlns:a16="http://schemas.microsoft.com/office/drawing/2014/main" id="{5E986198-3874-4C38-A9B5-E7D2156DEB78}"/>
               </a:ext>
             </a:extLst>
           </p:cNvPr>
@@ -10698,7 +10594,7 @@
           <p:cNvPr id="64" name="">
             <a:extLst xmlns:a="http://schemas.openxmlformats.org/drawingml/2006/main">
               <a:ext uri="{FF2B5EF4-FFF2-40B4-BE49-F238E27FC236}">
-                <a16:creationId xmlns:a16="http://schemas.microsoft.com/office/drawing/2014/main" id="{4D2EC51C-3708-48B7-B917-86D5A3B3A303}"/>
+                <a16:creationId xmlns:a16="http://schemas.microsoft.com/office/drawing/2014/main" id="{FC839805-284B-457D-8793-683C38E2CC58}"/>
               </a:ext>
             </a:extLst>
           </p:cNvPr>
@@ -10730,7 +10626,7 @@
           <p:cNvPr id="63" name="">
             <a:extLst xmlns:a="http://schemas.openxmlformats.org/drawingml/2006/main">
               <a:ext uri="{FF2B5EF4-FFF2-40B4-BE49-F238E27FC236}">
-                <a16:creationId xmlns:a16="http://schemas.microsoft.com/office/drawing/2014/main" id="{614B875E-A4E8-4CD8-8780-447505A575AF}"/>
+                <a16:creationId xmlns:a16="http://schemas.microsoft.com/office/drawing/2014/main" id="{3B53BA05-AF6D-49E1-BB69-8BA239F4DED0}"/>
               </a:ext>
             </a:extLst>
           </p:cNvPr>
@@ -10762,7 +10658,7 @@
           <p:cNvPr id="62" name="">
             <a:extLst xmlns:a="http://schemas.openxmlformats.org/drawingml/2006/main">
               <a:ext uri="{FF2B5EF4-FFF2-40B4-BE49-F238E27FC236}">
-                <a16:creationId xmlns:a16="http://schemas.microsoft.com/office/drawing/2014/main" id="{83F37278-B794-4E2B-9E44-31DCB152D17C}"/>
+                <a16:creationId xmlns:a16="http://schemas.microsoft.com/office/drawing/2014/main" id="{430B47F3-8357-48C3-AE9B-A714DF16C3EA}"/>
               </a:ext>
             </a:extLst>
           </p:cNvPr>
@@ -10797,7 +10693,7 @@
           <p:cNvPr id="61" name="">
             <a:extLst xmlns:a="http://schemas.openxmlformats.org/drawingml/2006/main">
               <a:ext uri="{FF2B5EF4-FFF2-40B4-BE49-F238E27FC236}">
-                <a16:creationId xmlns:a16="http://schemas.microsoft.com/office/drawing/2014/main" id="{B8280BF2-D00B-42A7-B638-20072671164F}"/>
+                <a16:creationId xmlns:a16="http://schemas.microsoft.com/office/drawing/2014/main" id="{699EAA9B-BB2F-4F75-A8E6-FF0AF75AA9E3}"/>
               </a:ext>
             </a:extLst>
           </p:cNvPr>
@@ -10832,7 +10728,7 @@
           <p:cNvPr id="36" name="">
             <a:extLst xmlns:a="http://schemas.openxmlformats.org/drawingml/2006/main">
               <a:ext uri="{FF2B5EF4-FFF2-40B4-BE49-F238E27FC236}">
-                <a16:creationId xmlns:a16="http://schemas.microsoft.com/office/drawing/2014/main" id="{D9882651-09E3-4CF6-B21E-28186AA5974F}"/>
+                <a16:creationId xmlns:a16="http://schemas.microsoft.com/office/drawing/2014/main" id="{9FCEC86A-A2BE-46C0-965E-19585778761A}"/>
               </a:ext>
             </a:extLst>
           </p:cNvPr>
@@ -14504,7 +14400,7 @@
           <p:cNvPr id="97" name="">
             <a:extLst xmlns:a="http://schemas.openxmlformats.org/drawingml/2006/main">
               <a:ext uri="{FF2B5EF4-FFF2-40B4-BE49-F238E27FC236}">
-                <a16:creationId xmlns:a16="http://schemas.microsoft.com/office/drawing/2014/main" id="{D7F5D435-CD85-46AB-97B1-E5F5D61F8EA2}"/>
+                <a16:creationId xmlns:a16="http://schemas.microsoft.com/office/drawing/2014/main" id="{2309A77F-0D94-4D8F-A15F-81987EC3C5CE}"/>
               </a:ext>
             </a:extLst>
           </p:cNvPr>
@@ -14532,7 +14428,9 @@
                     </a:bodyPr>
                     <a:lstStyle/>
                     <a:p>
-                      <a:pPr algn="l"/>
+                      <a:pPr algn="l">
+                        <a:buNone/>
+                      </a:pPr>
                       <a:r>
                         <a:rPr sz="1013" b="1">
                           <a:solidFill>
@@ -14559,7 +14457,9 @@
                     </a:bodyPr>
                     <a:lstStyle/>
                     <a:p>
-                      <a:pPr algn="ctr"/>
+                      <a:pPr algn="ctr">
+                        <a:buNone/>
+                      </a:pPr>
                       <a:r>
                         <a:rPr sz="1013" b="1">
                           <a:solidFill>
@@ -14586,7 +14486,9 @@
                     </a:bodyPr>
                     <a:lstStyle/>
                     <a:p>
-                      <a:pPr algn="ctr"/>
+                      <a:pPr algn="ctr">
+                        <a:buNone/>
+                      </a:pPr>
                       <a:r>
                         <a:rPr sz="1013" b="1">
                           <a:solidFill>
@@ -14615,7 +14517,9 @@
                     </a:bodyPr>
                     <a:lstStyle/>
                     <a:p>
-                      <a:pPr algn="l"/>
+                      <a:pPr algn="l">
+                        <a:buNone/>
+                      </a:pPr>
                       <a:r>
                         <a:rPr sz="990" b="1">
                           <a:solidFill>
@@ -14642,7 +14546,9 @@
                     </a:bodyPr>
                     <a:lstStyle/>
                     <a:p>
-                      <a:pPr algn="ctr"/>
+                      <a:pPr algn="ctr">
+                        <a:buNone/>
+                      </a:pPr>
                       <a:r>
                         <a:rPr sz="990" b="0">
                           <a:solidFill>
@@ -14669,7 +14575,9 @@
                     </a:bodyPr>
                     <a:lstStyle/>
                     <a:p>
-                      <a:pPr algn="ctr"/>
+                      <a:pPr algn="ctr">
+                        <a:buNone/>
+                      </a:pPr>
                       <a:r>
                         <a:rPr sz="990" b="0">
                           <a:solidFill>
@@ -14698,7 +14606,9 @@
                     </a:bodyPr>
                     <a:lstStyle/>
                     <a:p>
-                      <a:pPr algn="l"/>
+                      <a:pPr algn="l">
+                        <a:buNone/>
+                      </a:pPr>
                       <a:r>
                         <a:rPr sz="990" b="1">
                           <a:solidFill>
@@ -14725,7 +14635,9 @@
                     </a:bodyPr>
                     <a:lstStyle/>
                     <a:p>
-                      <a:pPr algn="ctr"/>
+                      <a:pPr algn="ctr">
+                        <a:buNone/>
+                      </a:pPr>
                       <a:r>
                         <a:rPr sz="990" b="0">
                           <a:solidFill>
@@ -14752,7 +14664,9 @@
                     </a:bodyPr>
                     <a:lstStyle/>
                     <a:p>
-                      <a:pPr algn="ctr"/>
+                      <a:pPr algn="ctr">
+                        <a:buNone/>
+                      </a:pPr>
                       <a:r>
                         <a:rPr sz="990" b="0">
                           <a:solidFill>
@@ -14781,7 +14695,9 @@
                     </a:bodyPr>
                     <a:lstStyle/>
                     <a:p>
-                      <a:pPr algn="l"/>
+                      <a:pPr algn="l">
+                        <a:buNone/>
+                      </a:pPr>
                       <a:r>
                         <a:rPr sz="990" b="1">
                           <a:solidFill>
@@ -14808,7 +14724,9 @@
                     </a:bodyPr>
                     <a:lstStyle/>
                     <a:p>
-                      <a:pPr algn="ctr"/>
+                      <a:pPr algn="ctr">
+                        <a:buNone/>
+                      </a:pPr>
                       <a:r>
                         <a:rPr sz="990" b="0">
                           <a:solidFill>
@@ -14835,7 +14753,9 @@
                     </a:bodyPr>
                     <a:lstStyle/>
                     <a:p>
-                      <a:pPr algn="ctr"/>
+                      <a:pPr algn="ctr">
+                        <a:buNone/>
+                      </a:pPr>
                       <a:r>
                         <a:rPr sz="990" b="0">
                           <a:solidFill>
@@ -14864,7 +14784,9 @@
                     </a:bodyPr>
                     <a:lstStyle/>
                     <a:p>
-                      <a:pPr algn="l"/>
+                      <a:pPr algn="l">
+                        <a:buNone/>
+                      </a:pPr>
                       <a:r>
                         <a:rPr sz="990" b="1">
                           <a:solidFill>
@@ -14891,7 +14813,9 @@
                     </a:bodyPr>
                     <a:lstStyle/>
                     <a:p>
-                      <a:pPr algn="ctr"/>
+                      <a:pPr algn="ctr">
+                        <a:buNone/>
+                      </a:pPr>
                       <a:r>
                         <a:rPr sz="990" b="0">
                           <a:solidFill>
@@ -14918,7 +14842,9 @@
                     </a:bodyPr>
                     <a:lstStyle/>
                     <a:p>
-                      <a:pPr algn="ctr"/>
+                      <a:pPr algn="ctr">
+                        <a:buNone/>
+                      </a:pPr>
                       <a:r>
                         <a:rPr sz="990" b="0">
                           <a:solidFill>
@@ -14947,7 +14873,9 @@
                     </a:bodyPr>
                     <a:lstStyle/>
                     <a:p>
-                      <a:pPr algn="l"/>
+                      <a:pPr algn="l">
+                        <a:buNone/>
+                      </a:pPr>
                       <a:r>
                         <a:rPr sz="990" b="1">
                           <a:solidFill>
@@ -14974,7 +14902,9 @@
                     </a:bodyPr>
                     <a:lstStyle/>
                     <a:p>
-                      <a:pPr algn="ctr"/>
+                      <a:pPr algn="ctr">
+                        <a:buNone/>
+                      </a:pPr>
                       <a:r>
                         <a:rPr sz="990" b="0">
                           <a:solidFill>
@@ -15001,7 +14931,9 @@
                     </a:bodyPr>
                     <a:lstStyle/>
                     <a:p>
-                      <a:pPr algn="ctr"/>
+                      <a:pPr algn="ctr">
+                        <a:buNone/>
+                      </a:pPr>
                       <a:r>
                         <a:rPr sz="990" b="0">
                           <a:solidFill>
@@ -15030,7 +14962,9 @@
                     </a:bodyPr>
                     <a:lstStyle/>
                     <a:p>
-                      <a:pPr algn="l"/>
+                      <a:pPr algn="l">
+                        <a:buNone/>
+                      </a:pPr>
                       <a:r>
                         <a:rPr sz="990" b="1">
                           <a:solidFill>
@@ -15057,7 +14991,9 @@
                     </a:bodyPr>
                     <a:lstStyle/>
                     <a:p>
-                      <a:pPr algn="ctr"/>
+                      <a:pPr algn="ctr">
+                        <a:buNone/>
+                      </a:pPr>
                       <a:r>
                         <a:rPr sz="990" b="0">
                           <a:solidFill>
@@ -15084,7 +15020,9 @@
                     </a:bodyPr>
                     <a:lstStyle/>
                     <a:p>
-                      <a:pPr algn="ctr"/>
+                      <a:pPr algn="ctr">
+                        <a:buNone/>
+                      </a:pPr>
                       <a:r>
                         <a:rPr sz="990" b="0">
                           <a:solidFill>
@@ -15113,7 +15051,9 @@
                     </a:bodyPr>
                     <a:lstStyle/>
                     <a:p>
-                      <a:pPr algn="l"/>
+                      <a:pPr algn="l">
+                        <a:buNone/>
+                      </a:pPr>
                       <a:r>
                         <a:rPr sz="990" b="1">
                           <a:solidFill>
@@ -15140,7 +15080,9 @@
                     </a:bodyPr>
                     <a:lstStyle/>
                     <a:p>
-                      <a:pPr algn="ctr"/>
+                      <a:pPr algn="ctr">
+                        <a:buNone/>
+                      </a:pPr>
                       <a:r>
                         <a:rPr sz="990" b="0">
                           <a:solidFill>
@@ -15167,7 +15109,9 @@
                     </a:bodyPr>
                     <a:lstStyle/>
                     <a:p>
-                      <a:pPr algn="ctr"/>
+                      <a:pPr algn="ctr">
+                        <a:buNone/>
+                      </a:pPr>
                       <a:r>
                         <a:rPr sz="990" b="0">
                           <a:solidFill>
@@ -15196,7 +15140,9 @@
                     </a:bodyPr>
                     <a:lstStyle/>
                     <a:p>
-                      <a:pPr algn="l"/>
+                      <a:pPr algn="l">
+                        <a:buNone/>
+                      </a:pPr>
                       <a:r>
                         <a:rPr sz="990" b="1">
                           <a:solidFill>
@@ -15223,7 +15169,9 @@
                     </a:bodyPr>
                     <a:lstStyle/>
                     <a:p>
-                      <a:pPr algn="ctr"/>
+                      <a:pPr algn="ctr">
+                        <a:buNone/>
+                      </a:pPr>
                       <a:r>
                         <a:rPr sz="990" b="0">
                           <a:solidFill>
@@ -15250,7 +15198,9 @@
                     </a:bodyPr>
                     <a:lstStyle/>
                     <a:p>
-                      <a:pPr algn="ctr"/>
+                      <a:pPr algn="ctr">
+                        <a:buNone/>
+                      </a:pPr>
                       <a:r>
                         <a:rPr sz="990" b="0">
                           <a:solidFill>
@@ -15279,7 +15229,9 @@
                     </a:bodyPr>
                     <a:lstStyle/>
                     <a:p>
-                      <a:pPr algn="l"/>
+                      <a:pPr algn="l">
+                        <a:buNone/>
+                      </a:pPr>
                       <a:r>
                         <a:rPr sz="990" b="1">
                           <a:solidFill>
@@ -15306,7 +15258,9 @@
                     </a:bodyPr>
                     <a:lstStyle/>
                     <a:p>
-                      <a:pPr algn="ctr"/>
+                      <a:pPr algn="ctr">
+                        <a:buNone/>
+                      </a:pPr>
                       <a:r>
                         <a:rPr sz="990" b="0">
                           <a:solidFill>
@@ -15333,7 +15287,9 @@
                     </a:bodyPr>
                     <a:lstStyle/>
                     <a:p>
-                      <a:pPr algn="ctr"/>
+                      <a:pPr algn="ctr">
+                        <a:buNone/>
+                      </a:pPr>
                       <a:r>
                         <a:rPr sz="990" b="0">
                           <a:solidFill>
@@ -15362,7 +15318,9 @@
                     </a:bodyPr>
                     <a:lstStyle/>
                     <a:p>
-                      <a:pPr algn="l"/>
+                      <a:pPr algn="l">
+                        <a:buNone/>
+                      </a:pPr>
                       <a:r>
                         <a:rPr sz="990" b="1">
                           <a:solidFill>
@@ -15389,7 +15347,9 @@
                     </a:bodyPr>
                     <a:lstStyle/>
                     <a:p>
-                      <a:pPr algn="ctr"/>
+                      <a:pPr algn="ctr">
+                        <a:buNone/>
+                      </a:pPr>
                       <a:r>
                         <a:rPr sz="990" b="0">
                           <a:solidFill>
@@ -15416,7 +15376,9 @@
                     </a:bodyPr>
                     <a:lstStyle/>
                     <a:p>
-                      <a:pPr algn="ctr"/>
+                      <a:pPr algn="ctr">
+                        <a:buNone/>
+                      </a:pPr>
                       <a:r>
                         <a:rPr sz="990" b="0">
                           <a:solidFill>
@@ -15445,7 +15407,9 @@
                     </a:bodyPr>
                     <a:lstStyle/>
                     <a:p>
-                      <a:pPr algn="l"/>
+                      <a:pPr algn="l">
+                        <a:buNone/>
+                      </a:pPr>
                       <a:r>
                         <a:rPr sz="990" b="1">
                           <a:solidFill>
@@ -15472,7 +15436,9 @@
                     </a:bodyPr>
                     <a:lstStyle/>
                     <a:p>
-                      <a:pPr algn="ctr"/>
+                      <a:pPr algn="ctr">
+                        <a:buNone/>
+                      </a:pPr>
                       <a:r>
                         <a:rPr sz="990" b="0">
                           <a:solidFill>
@@ -15499,7 +15465,9 @@
                     </a:bodyPr>
                     <a:lstStyle/>
                     <a:p>
-                      <a:pPr algn="ctr"/>
+                      <a:pPr algn="ctr">
+                        <a:buNone/>
+                      </a:pPr>
                       <a:r>
                         <a:rPr sz="990" b="0">
                           <a:solidFill>
@@ -15528,7 +15496,9 @@
                     </a:bodyPr>
                     <a:lstStyle/>
                     <a:p>
-                      <a:pPr algn="l"/>
+                      <a:pPr algn="l">
+                        <a:buNone/>
+                      </a:pPr>
                       <a:r>
                         <a:rPr sz="990" b="1">
                           <a:solidFill>
@@ -15555,7 +15525,9 @@
                     </a:bodyPr>
                     <a:lstStyle/>
                     <a:p>
-                      <a:pPr algn="ctr"/>
+                      <a:pPr algn="ctr">
+                        <a:buNone/>
+                      </a:pPr>
                       <a:r>
                         <a:rPr sz="990" b="0">
                           <a:solidFill>
@@ -15582,7 +15554,9 @@
                     </a:bodyPr>
                     <a:lstStyle/>
                     <a:p>
-                      <a:pPr algn="ctr"/>
+                      <a:pPr algn="ctr">
+                        <a:buNone/>
+                      </a:pPr>
                       <a:r>
                         <a:rPr sz="990" b="0">
                           <a:solidFill>
@@ -15611,7 +15585,9 @@
                     </a:bodyPr>
                     <a:lstStyle/>
                     <a:p>
-                      <a:pPr algn="l"/>
+                      <a:pPr algn="l">
+                        <a:buNone/>
+                      </a:pPr>
                       <a:r>
                         <a:rPr sz="990" b="1">
                           <a:solidFill>
@@ -15638,7 +15614,9 @@
                     </a:bodyPr>
                     <a:lstStyle/>
                     <a:p>
-                      <a:pPr algn="ctr"/>
+                      <a:pPr algn="ctr">
+                        <a:buNone/>
+                      </a:pPr>
                       <a:r>
                         <a:rPr sz="990" b="0">
                           <a:solidFill>
@@ -15665,7 +15643,9 @@
                     </a:bodyPr>
                     <a:lstStyle/>
                     <a:p>
-                      <a:pPr algn="ctr"/>
+                      <a:pPr algn="ctr">
+                        <a:buNone/>
+                      </a:pPr>
                       <a:r>
                         <a:rPr sz="990" b="0">
                           <a:solidFill>
@@ -15694,7 +15674,9 @@
                     </a:bodyPr>
                     <a:lstStyle/>
                     <a:p>
-                      <a:pPr algn="l"/>
+                      <a:pPr algn="l">
+                        <a:buNone/>
+                      </a:pPr>
                       <a:r>
                         <a:rPr sz="990" b="1">
                           <a:solidFill>
@@ -15721,7 +15703,9 @@
                     </a:bodyPr>
                     <a:lstStyle/>
                     <a:p>
-                      <a:pPr algn="ctr"/>
+                      <a:pPr algn="ctr">
+                        <a:buNone/>
+                      </a:pPr>
                       <a:r>
                         <a:rPr sz="990" b="0">
                           <a:solidFill>
@@ -15748,7 +15732,9 @@
                     </a:bodyPr>
                     <a:lstStyle/>
                     <a:p>
-                      <a:pPr algn="ctr"/>
+                      <a:pPr algn="ctr">
+                        <a:buNone/>
+                      </a:pPr>
                       <a:r>
                         <a:rPr sz="990" b="0">
                           <a:solidFill>
@@ -15777,7 +15763,9 @@
                     </a:bodyPr>
                     <a:lstStyle/>
                     <a:p>
-                      <a:pPr algn="l"/>
+                      <a:pPr algn="l">
+                        <a:buNone/>
+                      </a:pPr>
                       <a:r>
                         <a:rPr sz="990" b="1">
                           <a:solidFill>
@@ -15804,7 +15792,9 @@
                     </a:bodyPr>
                     <a:lstStyle/>
                     <a:p>
-                      <a:pPr algn="ctr"/>
+                      <a:pPr algn="ctr">
+                        <a:buNone/>
+                      </a:pPr>
                       <a:r>
                         <a:rPr sz="990" b="0">
                           <a:solidFill>
@@ -15831,7 +15821,9 @@
                     </a:bodyPr>
                     <a:lstStyle/>
                     <a:p>
-                      <a:pPr algn="ctr"/>
+                      <a:pPr algn="ctr">
+                        <a:buNone/>
+                      </a:pPr>
                       <a:r>
                         <a:rPr sz="990" b="0">
                           <a:solidFill>
@@ -15860,7 +15852,9 @@
                     </a:bodyPr>
                     <a:lstStyle/>
                     <a:p>
-                      <a:pPr algn="l"/>
+                      <a:pPr algn="l">
+                        <a:buNone/>
+                      </a:pPr>
                       <a:r>
                         <a:rPr sz="990" b="1">
                           <a:solidFill>
@@ -15887,7 +15881,9 @@
                     </a:bodyPr>
                     <a:lstStyle/>
                     <a:p>
-                      <a:pPr algn="ctr"/>
+                      <a:pPr algn="ctr">
+                        <a:buNone/>
+                      </a:pPr>
                       <a:r>
                         <a:rPr sz="990" b="0">
                           <a:solidFill>
@@ -15914,7 +15910,9 @@
                     </a:bodyPr>
                     <a:lstStyle/>
                     <a:p>
-                      <a:pPr algn="ctr"/>
+                      <a:pPr algn="ctr">
+                        <a:buNone/>
+                      </a:pPr>
                       <a:r>
                         <a:rPr sz="990" b="0">
                           <a:solidFill>
@@ -15944,7 +15942,7 @@
           <p:cNvPr id="98" name="">
             <a:extLst xmlns:a="http://schemas.openxmlformats.org/drawingml/2006/main">
               <a:ext uri="{FF2B5EF4-FFF2-40B4-BE49-F238E27FC236}">
-                <a16:creationId xmlns:a16="http://schemas.microsoft.com/office/drawing/2014/main" id="{2218F365-EC05-4977-9727-76B61FF1EDB8}"/>
+                <a16:creationId xmlns:a16="http://schemas.microsoft.com/office/drawing/2014/main" id="{162B9213-E967-4876-9F41-3658D784F7FC}"/>
               </a:ext>
             </a:extLst>
           </p:cNvPr>
@@ -15972,7 +15970,9 @@
                     </a:bodyPr>
                     <a:lstStyle/>
                     <a:p>
-                      <a:pPr algn="l"/>
+                      <a:pPr algn="l">
+                        <a:buNone/>
+                      </a:pPr>
                       <a:r>
                         <a:rPr sz="1013" b="1">
                           <a:solidFill>
@@ -15999,7 +15999,9 @@
                     </a:bodyPr>
                     <a:lstStyle/>
                     <a:p>
-                      <a:pPr algn="ctr"/>
+                      <a:pPr algn="ctr">
+                        <a:buNone/>
+                      </a:pPr>
                       <a:r>
                         <a:rPr sz="1013" b="1">
                           <a:solidFill>
@@ -16026,7 +16028,9 @@
                     </a:bodyPr>
                     <a:lstStyle/>
                     <a:p>
-                      <a:pPr algn="ctr"/>
+                      <a:pPr algn="ctr">
+                        <a:buNone/>
+                      </a:pPr>
                       <a:r>
                         <a:rPr sz="1013" b="1">
                           <a:solidFill>
@@ -16055,7 +16059,9 @@
                     </a:bodyPr>
                     <a:lstStyle/>
                     <a:p>
-                      <a:pPr algn="l"/>
+                      <a:pPr algn="l">
+                        <a:buNone/>
+                      </a:pPr>
                       <a:r>
                         <a:rPr sz="990" b="1">
                           <a:solidFill>
@@ -16082,7 +16088,9 @@
                     </a:bodyPr>
                     <a:lstStyle/>
                     <a:p>
-                      <a:pPr algn="ctr"/>
+                      <a:pPr algn="ctr">
+                        <a:buNone/>
+                      </a:pPr>
                       <a:r>
                         <a:rPr sz="990" b="0">
                           <a:solidFill>
@@ -16109,7 +16117,9 @@
                     </a:bodyPr>
                     <a:lstStyle/>
                     <a:p>
-                      <a:pPr algn="ctr"/>
+                      <a:pPr algn="ctr">
+                        <a:buNone/>
+                      </a:pPr>
                       <a:r>
                         <a:rPr sz="990" b="0">
                           <a:solidFill>
@@ -16138,7 +16148,9 @@
                     </a:bodyPr>
                     <a:lstStyle/>
                     <a:p>
-                      <a:pPr algn="l"/>
+                      <a:pPr algn="l">
+                        <a:buNone/>
+                      </a:pPr>
                       <a:r>
                         <a:rPr sz="990" b="1">
                           <a:solidFill>
@@ -16165,7 +16177,9 @@
                     </a:bodyPr>
                     <a:lstStyle/>
                     <a:p>
-                      <a:pPr algn="ctr"/>
+                      <a:pPr algn="ctr">
+                        <a:buNone/>
+                      </a:pPr>
                       <a:r>
                         <a:rPr sz="990" b="0">
                           <a:solidFill>
@@ -16192,7 +16206,9 @@
                     </a:bodyPr>
                     <a:lstStyle/>
                     <a:p>
-                      <a:pPr algn="ctr"/>
+                      <a:pPr algn="ctr">
+                        <a:buNone/>
+                      </a:pPr>
                       <a:r>
                         <a:rPr sz="990" b="0">
                           <a:solidFill>
@@ -16221,7 +16237,9 @@
                     </a:bodyPr>
                     <a:lstStyle/>
                     <a:p>
-                      <a:pPr algn="l"/>
+                      <a:pPr algn="l">
+                        <a:buNone/>
+                      </a:pPr>
                       <a:r>
                         <a:rPr sz="990" b="1">
                           <a:solidFill>
@@ -16248,7 +16266,9 @@
                     </a:bodyPr>
                     <a:lstStyle/>
                     <a:p>
-                      <a:pPr algn="ctr"/>
+                      <a:pPr algn="ctr">
+                        <a:buNone/>
+                      </a:pPr>
                       <a:r>
                         <a:rPr sz="990" b="0">
                           <a:solidFill>
@@ -16275,7 +16295,9 @@
                     </a:bodyPr>
                     <a:lstStyle/>
                     <a:p>
-                      <a:pPr algn="ctr"/>
+                      <a:pPr algn="ctr">
+                        <a:buNone/>
+                      </a:pPr>
                       <a:r>
                         <a:rPr sz="990" b="0">
                           <a:solidFill>
@@ -16304,7 +16326,9 @@
                     </a:bodyPr>
                     <a:lstStyle/>
                     <a:p>
-                      <a:pPr algn="l"/>
+                      <a:pPr algn="l">
+                        <a:buNone/>
+                      </a:pPr>
                       <a:r>
                         <a:rPr sz="990" b="1">
                           <a:solidFill>
@@ -16331,7 +16355,9 @@
                     </a:bodyPr>
                     <a:lstStyle/>
                     <a:p>
-                      <a:pPr algn="ctr"/>
+                      <a:pPr algn="ctr">
+                        <a:buNone/>
+                      </a:pPr>
                       <a:r>
                         <a:rPr sz="990" b="0">
                           <a:solidFill>
@@ -16358,7 +16384,9 @@
                     </a:bodyPr>
                     <a:lstStyle/>
                     <a:p>
-                      <a:pPr algn="ctr"/>
+                      <a:pPr algn="ctr">
+                        <a:buNone/>
+                      </a:pPr>
                       <a:r>
                         <a:rPr sz="990" b="0">
                           <a:solidFill>
@@ -16387,7 +16415,9 @@
                     </a:bodyPr>
                     <a:lstStyle/>
                     <a:p>
-                      <a:pPr algn="l"/>
+                      <a:pPr algn="l">
+                        <a:buNone/>
+                      </a:pPr>
                       <a:r>
                         <a:rPr sz="990" b="1">
                           <a:solidFill>
@@ -16414,7 +16444,9 @@
                     </a:bodyPr>
                     <a:lstStyle/>
                     <a:p>
-                      <a:pPr algn="ctr"/>
+                      <a:pPr algn="ctr">
+                        <a:buNone/>
+                      </a:pPr>
                       <a:r>
                         <a:rPr sz="990" b="0">
                           <a:solidFill>
@@ -16441,7 +16473,9 @@
                     </a:bodyPr>
                     <a:lstStyle/>
                     <a:p>
-                      <a:pPr algn="ctr"/>
+                      <a:pPr algn="ctr">
+                        <a:buNone/>
+                      </a:pPr>
                       <a:r>
                         <a:rPr sz="990" b="0">
                           <a:solidFill>
@@ -16470,7 +16504,9 @@
                     </a:bodyPr>
                     <a:lstStyle/>
                     <a:p>
-                      <a:pPr algn="l"/>
+                      <a:pPr algn="l">
+                        <a:buNone/>
+                      </a:pPr>
                       <a:r>
                         <a:rPr sz="990" b="1">
                           <a:solidFill>
@@ -16497,7 +16533,9 @@
                     </a:bodyPr>
                     <a:lstStyle/>
                     <a:p>
-                      <a:pPr algn="ctr"/>
+                      <a:pPr algn="ctr">
+                        <a:buNone/>
+                      </a:pPr>
                       <a:r>
                         <a:rPr sz="990" b="0">
                           <a:solidFill>
@@ -16524,7 +16562,9 @@
                     </a:bodyPr>
                     <a:lstStyle/>
                     <a:p>
-                      <a:pPr algn="ctr"/>
+                      <a:pPr algn="ctr">
+                        <a:buNone/>
+                      </a:pPr>
                       <a:r>
                         <a:rPr sz="990" b="0">
                           <a:solidFill>
@@ -16553,7 +16593,9 @@
                     </a:bodyPr>
                     <a:lstStyle/>
                     <a:p>
-                      <a:pPr algn="l"/>
+                      <a:pPr algn="l">
+                        <a:buNone/>
+                      </a:pPr>
                       <a:r>
                         <a:rPr sz="990" b="1">
                           <a:solidFill>
@@ -16580,7 +16622,9 @@
                     </a:bodyPr>
                     <a:lstStyle/>
                     <a:p>
-                      <a:pPr algn="ctr"/>
+                      <a:pPr algn="ctr">
+                        <a:buNone/>
+                      </a:pPr>
                       <a:r>
                         <a:rPr sz="990" b="0">
                           <a:solidFill>
@@ -16607,7 +16651,9 @@
                     </a:bodyPr>
                     <a:lstStyle/>
                     <a:p>
-                      <a:pPr algn="ctr"/>
+                      <a:pPr algn="ctr">
+                        <a:buNone/>
+                      </a:pPr>
                       <a:r>
                         <a:rPr sz="990" b="0">
                           <a:solidFill>
@@ -16636,7 +16682,9 @@
                     </a:bodyPr>
                     <a:lstStyle/>
                     <a:p>
-                      <a:pPr algn="l"/>
+                      <a:pPr algn="l">
+                        <a:buNone/>
+                      </a:pPr>
                       <a:r>
                         <a:rPr sz="990" b="1">
                           <a:solidFill>
@@ -16663,7 +16711,9 @@
                     </a:bodyPr>
                     <a:lstStyle/>
                     <a:p>
-                      <a:pPr algn="ctr"/>
+                      <a:pPr algn="ctr">
+                        <a:buNone/>
+                      </a:pPr>
                       <a:r>
                         <a:rPr sz="990" b="0">
                           <a:solidFill>
@@ -16690,7 +16740,9 @@
                     </a:bodyPr>
                     <a:lstStyle/>
                     <a:p>
-                      <a:pPr algn="ctr"/>
+                      <a:pPr algn="ctr">
+                        <a:buNone/>
+                      </a:pPr>
                       <a:r>
                         <a:rPr sz="990" b="0">
                           <a:solidFill>
@@ -16719,7 +16771,9 @@
                     </a:bodyPr>
                     <a:lstStyle/>
                     <a:p>
-                      <a:pPr algn="l"/>
+                      <a:pPr algn="l">
+                        <a:buNone/>
+                      </a:pPr>
                       <a:r>
                         <a:rPr sz="990" b="1">
                           <a:solidFill>
@@ -16746,7 +16800,9 @@
                     </a:bodyPr>
                     <a:lstStyle/>
                     <a:p>
-                      <a:pPr algn="ctr"/>
+                      <a:pPr algn="ctr">
+                        <a:buNone/>
+                      </a:pPr>
                       <a:r>
                         <a:rPr sz="990" b="0">
                           <a:solidFill>
@@ -16773,7 +16829,9 @@
                     </a:bodyPr>
                     <a:lstStyle/>
                     <a:p>
-                      <a:pPr algn="ctr"/>
+                      <a:pPr algn="ctr">
+                        <a:buNone/>
+                      </a:pPr>
                       <a:r>
                         <a:rPr sz="990" b="0">
                           <a:solidFill>
@@ -19433,7 +19491,7 @@
           <p:cNvPr id="32" name="">
             <a:extLst xmlns:a="http://schemas.openxmlformats.org/drawingml/2006/main">
               <a:ext uri="{FF2B5EF4-FFF2-40B4-BE49-F238E27FC236}">
-                <a16:creationId xmlns:a16="http://schemas.microsoft.com/office/drawing/2014/main" id="{94480C8E-F1E7-4437-B752-2C568BE51988}"/>
+                <a16:creationId xmlns:a16="http://schemas.microsoft.com/office/drawing/2014/main" id="{AA481E83-EC99-4811-809E-191CF07115E4}"/>
               </a:ext>
             </a:extLst>
           </p:cNvPr>
@@ -19465,7 +19523,7 @@
           <p:cNvPr id="31" name="">
             <a:extLst xmlns:a="http://schemas.openxmlformats.org/drawingml/2006/main">
               <a:ext uri="{FF2B5EF4-FFF2-40B4-BE49-F238E27FC236}">
-                <a16:creationId xmlns:a16="http://schemas.microsoft.com/office/drawing/2014/main" id="{4B6D26BB-BC70-4E4B-B404-735056A08A90}"/>
+                <a16:creationId xmlns:a16="http://schemas.microsoft.com/office/drawing/2014/main" id="{4C5BE5C8-B917-4BBD-BF74-FC51ACBCCF0E}"/>
               </a:ext>
             </a:extLst>
           </p:cNvPr>
@@ -19497,7 +19555,7 @@
           <p:cNvPr id="30" name="">
             <a:extLst xmlns:a="http://schemas.openxmlformats.org/drawingml/2006/main">
               <a:ext uri="{FF2B5EF4-FFF2-40B4-BE49-F238E27FC236}">
-                <a16:creationId xmlns:a16="http://schemas.microsoft.com/office/drawing/2014/main" id="{972A741A-2B90-4BAC-BAE9-5957B7965DB2}"/>
+                <a16:creationId xmlns:a16="http://schemas.microsoft.com/office/drawing/2014/main" id="{F3FC5538-4706-4612-9B2C-42D6DB1C4C12}"/>
               </a:ext>
             </a:extLst>
           </p:cNvPr>
@@ -20973,7 +21031,7 @@
           <p:cNvPr id="35" name="">
             <a:extLst xmlns:a="http://schemas.openxmlformats.org/drawingml/2006/main">
               <a:ext uri="{FF2B5EF4-FFF2-40B4-BE49-F238E27FC236}">
-                <a16:creationId xmlns:a16="http://schemas.microsoft.com/office/drawing/2014/main" id="{ADD739EB-BDCC-4FAD-9359-631219E26E69}"/>
+                <a16:creationId xmlns:a16="http://schemas.microsoft.com/office/drawing/2014/main" id="{088A0190-D161-4B6A-802C-641AA9B8DDC8}"/>
               </a:ext>
             </a:extLst>
           </p:cNvPr>
@@ -21005,7 +21063,7 @@
           <p:cNvPr id="34" name="">
             <a:extLst xmlns:a="http://schemas.openxmlformats.org/drawingml/2006/main">
               <a:ext uri="{FF2B5EF4-FFF2-40B4-BE49-F238E27FC236}">
-                <a16:creationId xmlns:a16="http://schemas.microsoft.com/office/drawing/2014/main" id="{A6F6C5BA-D5C0-4635-A086-9B8171C1C936}"/>
+                <a16:creationId xmlns:a16="http://schemas.microsoft.com/office/drawing/2014/main" id="{3AB8A623-BA8A-410F-8EAD-ED08B9D72692}"/>
               </a:ext>
             </a:extLst>
           </p:cNvPr>
@@ -21037,7 +21095,7 @@
           <p:cNvPr id="33" name="">
             <a:extLst xmlns:a="http://schemas.openxmlformats.org/drawingml/2006/main">
               <a:ext uri="{FF2B5EF4-FFF2-40B4-BE49-F238E27FC236}">
-                <a16:creationId xmlns:a16="http://schemas.microsoft.com/office/drawing/2014/main" id="{39F040E9-C604-456B-A7E1-9FAA0C195096}"/>
+                <a16:creationId xmlns:a16="http://schemas.microsoft.com/office/drawing/2014/main" id="{A345AED5-0896-4375-8886-CD20757F1C54}"/>
               </a:ext>
             </a:extLst>
           </p:cNvPr>

</xml_diff>